<commit_message>
feat: consent before sharing, care contacts on the summary, clinician packet, layout fix
Sharing the summary asks for consent first and offers a picture or plain text.
The slip shows care contacts with their confirmation status. A rule stops
buttons being squeezed on short screens. Adds the generated clinician review
packet, the backlog status, an updated accessibility report and the deck with
the current test count.

Co-Authored-By: Claude Sonnet 5.5 <noreply@anthropic.com>
Claude-Session: https://claude.ai/code/session_019UcpKkURiWkYwbNzPaVJbj
</commit_message>
<xml_diff>
--- a/docs/Maitri-recHERsion-2026.pptx
+++ b/docs/Maitri-recHERsion-2026.pptx
@@ -122,14 +122,14 @@
   <p:extLst>
     <p:ext uri="{521415D9-36F7-43E2-AB2F-B90AF26B5E84}">
       <p14:sectionLst xmlns:p14="http://schemas.microsoft.com/office/powerpoint/2010/main">
-        <p14:section name="Opening" id="{27170f14-c117-95a4-0ffc-3b53381cf5a4}">
+        <p14:section name="Opening" id="{5aafcb15-0c93-0806-7592-c4e02bd0101b}">
           <p14:sldIdLst>
             <p14:sldId id="256"/>
             <p14:sldId id="257"/>
             <p14:sldId id="258"/>
           </p14:sldIdLst>
         </p14:section>
-        <p14:section name="Solution" id="{73722153-0515-2fd1-42fd-75849b5dfb60}">
+        <p14:section name="Solution" id="{bbba32ed-a8ec-6418-6621-8717c5f09c5e}">
           <p14:sldIdLst>
             <p14:sldId id="259"/>
             <p14:sldId id="260"/>
@@ -137,14 +137,14 @@
             <p14:sldId id="262"/>
           </p14:sldIdLst>
         </p14:section>
-        <p14:section name="Trust and technology" id="{4f928db4-e83d-2645-b7ec-995d431ee527}">
+        <p14:section name="Trust and technology" id="{d3f2392a-0745-07f0-a376-b1ff9b014d76}">
           <p14:sldIdLst>
             <p14:sldId id="263"/>
             <p14:sldId id="264"/>
             <p14:sldId id="265"/>
           </p14:sldIdLst>
         </p14:section>
-        <p14:section name="Reality and impact" id="{b5605e2a-79f2-84a1-6865-250c42a7324e}">
+        <p14:section name="Reality and impact" id="{bbdfedea-acde-3c50-c0b2-9bca7b3a30eb}">
           <p14:sldIdLst>
             <p14:sldId id="266"/>
             <p14:sldId id="267"/>
@@ -11973,7 +11973,7 @@
                 <a:ea typeface="Cambria" pitchFamily="34" charset="-122"/>
                 <a:cs typeface="Cambria" pitchFamily="34" charset="-120"/>
               </a:rPr>
-              <a:t>108/108</a:t>
+              <a:t>188/188</a:t>
             </a:r>
             <a:endParaRPr lang="en-US" sz="4000" dirty="0"/>
           </a:p>

</xml_diff>